<commit_message>
Add pipeline evidence slide with Trivy scan and GHCR push screenshots
</commit_message>
<xml_diff>
--- a/docs/DataDrift-Capstone-Presentation.pptx
+++ b/docs/DataDrift-Capstone-Presentation.pptx
@@ -15,6 +15,7 @@
     <p:sldId id="263" r:id="rId9"/>
     <p:sldId id="264" r:id="rId10"/>
     <p:sldId id="265" r:id="rId11"/>
+    <p:sldId id="274" r:id="rId25"/>
     <p:sldId id="266" r:id="rId12"/>
     <p:sldId id="267" r:id="rId13"/>
     <p:sldId id="268" r:id="rId14"/>
@@ -140,6 +141,7 @@
             <p14:sldId id="263"/>
             <p14:sldId id="264"/>
             <p14:sldId id="265"/>
+            <p14:sldId id="274"/>
           </p14:sldIdLst>
         </p14:section>
         <p14:section name="Infrastructure and runtime" id="{78cfe018-5433-16d0-b51c-b7f525af8985}">
@@ -1389,6 +1391,76 @@
         <p14:creationId xmlns:p14="http://schemas.microsoft.com/office/powerpoint/2010/main" val="1024086991"/>
       </p:ext>
     </p:extLst>
+  </p:cSld>
+  <p:clrMapOvr>
+    <a:masterClrMapping/>
+  </p:clrMapOvr>
+</p:notes>
+</file>
+
+<file path=ppt/notesSlides/notesSlide19.xml><?xml version="1.0" encoding="utf-8"?>
+<p:notes xmlns:a="http://schemas.openxmlformats.org/drawingml/2006/main" xmlns:p="http://schemas.openxmlformats.org/presentationml/2006/main" xmlns:r="http://schemas.openxmlformats.org/officeDocument/2006/relationships">
+  <p:cSld>
+    <p:spTree>
+      <p:nvGrpSpPr>
+        <p:cNvPr id="1" name=""/>
+        <p:cNvGrpSpPr/>
+        <p:nvPr/>
+      </p:nvGrpSpPr>
+      <p:grpSpPr>
+        <a:xfrm>
+          <a:off x="0" y="0"/>
+          <a:ext cx="0" cy="0"/>
+          <a:chOff x="0" y="0"/>
+          <a:chExt cx="0" cy="0"/>
+        </a:xfrm>
+      </p:grpSpPr>
+      <p:sp>
+        <p:nvSpPr>
+          <p:cNvPr id="2" name="Slide Image Placeholder 1"/>
+          <p:cNvSpPr>
+            <a:spLocks noGrp="1"/>
+          </p:cNvSpPr>
+          <p:nvPr>
+            <p:ph type="sldImg" idx="2"/>
+          </p:nvPr>
+        </p:nvSpPr>
+        <p:spPr/>
+      </p:sp>
+      <p:sp>
+        <p:nvSpPr>
+          <p:cNvPr id="3" name="Notes Placeholder 2"/>
+          <p:cNvSpPr>
+            <a:spLocks noGrp="1"/>
+          </p:cNvSpPr>
+          <p:nvPr>
+            <p:ph type="body" idx="3" sz="quarter"/>
+          </p:nvPr>
+        </p:nvSpPr>
+        <p:spPr/>
+        <p:txBody>
+          <a:bodyPr/>
+          <a:lstStyle/>
+          <a:p>
+            <a:r>
+              <a:t>This is the evidence from a real pipeline run. On the left is the Trivy step inside the backend build job: it pulls Trivy 0.75, downloads the latest vulnerability database, and scans the Debian packages, the Python libraries and any secrets in the image. The step passed, so there were no fixable HIGH or CRITICAL CVEs. Only then does the job log in to the GitHub Container Registry with the workflow's built-in GITHUB_TOKEN, shown on the right, and push the image tagged with the commit SHA. If Trivy had found a problem, the job would have stopped before the push.</a:t>
+            </a:r>
+          </a:p>
+        </p:txBody>
+      </p:sp>
+      <p:sp>
+        <p:nvSpPr>
+          <p:cNvPr id="4" name="Slide Number Placeholder 3"/>
+          <p:cNvSpPr>
+            <a:spLocks noGrp="1"/>
+          </p:cNvSpPr>
+          <p:nvPr>
+            <p:ph type="sldNum" idx="5" sz="quarter"/>
+          </p:nvPr>
+        </p:nvSpPr>
+        <p:spPr/>
+      </p:sp>
+    </p:spTree>
   </p:cSld>
   <p:clrMapOvr>
     <a:masterClrMapping/>
@@ -3961,6 +4033,369 @@
 </file>
 
 <file path=ppt/slides/slide11.xml><?xml version="1.0" encoding="utf-8"?>
+<p:sld xmlns:a="http://schemas.openxmlformats.org/drawingml/2006/main" xmlns:p="http://schemas.openxmlformats.org/presentationml/2006/main" xmlns:r="http://schemas.openxmlformats.org/officeDocument/2006/relationships">
+  <p:cSld>
+    <p:spTree>
+      <p:nvGrpSpPr>
+        <p:cNvPr id="1" name=""/>
+        <p:cNvGrpSpPr/>
+        <p:nvPr/>
+      </p:nvGrpSpPr>
+      <p:grpSpPr/>
+      <p:sp>
+        <p:nvSpPr>
+          <p:cNvPr id="3" name="Text 0"/>
+          <p:cNvSpPr/>
+          <p:nvPr>
+            <p:ph idx="101" type="title" hasCustomPrompt="1"/>
+          </p:nvPr>
+        </p:nvSpPr>
+        <p:spPr>
+          <a:xfrm>
+            <a:off x="548640" y="621792"/>
+            <a:ext cx="11064240" cy="731520"/>
+          </a:xfrm>
+          <a:prstGeom prst="rect">
+            <a:avLst/>
+          </a:prstGeom>
+          <a:noFill/>
+          <a:ln/>
+        </p:spPr>
+        <p:txBody>
+          <a:bodyPr wrap="square" lIns="0" tIns="0" rIns="0" bIns="0" rtlCol="0" anchor="t"/>
+          <a:lstStyle/>
+          <a:p>
+            <a:pPr algn="l" indent="0" marL="0">
+              <a:buNone/>
+            </a:pPr>
+            <a:r>
+              <a:rPr lang="en-US" sz="3400" b="1" dirty="0">
+                <a:solidFill>
+                  <a:schemeClr val="tx1"/>
+                </a:solidFill>
+              </a:rPr>
+              <a:t>Scanned first, pushed only if clean</a:t>
+            </a:r>
+            <a:endParaRPr lang="en-US" sz="3400" dirty="0"/>
+          </a:p>
+        </p:txBody>
+      </p:sp>
+      <p:sp>
+        <p:nvSpPr>
+          <p:cNvPr id="2" name="Text 0"/>
+          <p:cNvSpPr/>
+          <p:nvPr>
+            <p:ph idx="100" type="body" hasCustomPrompt="1"/>
+          </p:nvPr>
+        </p:nvSpPr>
+        <p:spPr>
+          <a:xfrm>
+            <a:off x="548640" y="320040"/>
+            <a:ext cx="8229600" cy="292608"/>
+          </a:xfrm>
+          <a:prstGeom prst="rect">
+            <a:avLst/>
+          </a:prstGeom>
+          <a:noFill/>
+          <a:ln/>
+        </p:spPr>
+        <p:txBody>
+          <a:bodyPr wrap="square" lIns="0" tIns="0" rIns="0" bIns="0" rtlCol="0"/>
+          <a:lstStyle/>
+          <a:p>
+            <a:pPr indent="0" marL="0">
+              <a:buNone/>
+            </a:pPr>
+            <a:r>
+              <a:rPr lang="en-US" sz="1200" b="1" spc="200" kern="0" dirty="0">
+                <a:solidFill>
+                  <a:schemeClr val="accent1"/>
+                </a:solidFill>
+              </a:rPr>
+              <a:t>M5 + M6 · PIPELINE EVIDENCE</a:t>
+            </a:r>
+            <a:endParaRPr lang="en-US" sz="1200" dirty="0"/>
+          </a:p>
+        </p:txBody>
+      </p:sp>
+      <p:sp>
+        <p:nvSpPr>
+          <p:cNvPr id="25" name="Slide Number Placeholder 0"/>
+          <p:cNvSpPr>
+            <a:spLocks noGrp="1"/>
+          </p:cNvSpPr>
+          <p:nvPr>
+            <p:ph type="sldNum" sz="quarter" idx="4294967295"/>
+          </p:nvPr>
+        </p:nvSpPr>
+        <p:spPr>
+          <a:xfrm>
+            <a:off x="11183112" y="6473952"/>
+            <a:ext cx="457200" cy="274320"/>
+          </a:xfrm>
+          <a:prstGeom prst="rect">
+            <a:avLst/>
+          </a:prstGeom>
+          <a:extLst>
+            <a:ext uri="{C572A759-6A51-4108-AA02-DFA0A04FC94B}">
+              <ma14:wrappingTextBoxFlag xmlns:ma14="http://schemas.microsoft.com/office/mac/drawingml/2011/main" val="0"/>
+            </a:ext>
+          </a:extLst>
+        </p:spPr>
+        <p:txBody>
+          <a:bodyPr lIns="0" tIns="0" rIns="0" bIns="0"/>
+          <a:lstStyle>
+            <a:lvl1pPr>
+              <a:defRPr sz="1000">
+                <a:solidFill>
+                  <a:srgbClr val="64748B"/>
+                </a:solidFill>
+              </a:defRPr>
+            </a:lvl1pPr>
+          </a:lstStyle>
+          <a:p>
+            <a:pPr algn="r"/>
+            <a:fld id="{F7021451-1387-4CA6-816F-3879F97B5CBC}" type="slidenum">
+              <a:rPr b="0" lang="en-US"/>
+              <a:t>10</a:t>
+            </a:fld>
+            <a:endParaRPr lang="en-US"/>
+          </a:p>
+        </p:txBody>
+      </p:sp>
+      <p:sp>
+        <p:nvSpPr>
+          <p:cNvPr id="22" name="card 34-actions-trivy-scan.png"/>
+          <p:cNvSpPr/>
+          <p:nvPr/>
+        </p:nvSpPr>
+        <p:spPr>
+          <a:xfrm>
+            <a:off x="548640" y="1645920"/>
+            <a:ext cx="5541264" cy="3375398"/>
+          </a:xfrm>
+          <a:prstGeom prst="roundRect">
+            <a:avLst>
+              <a:gd name="adj" fmla="val 2039"/>
+            </a:avLst>
+          </a:prstGeom>
+          <a:solidFill>
+            <a:schemeClr val="bg1"/>
+          </a:solidFill>
+          <a:ln w="9525">
+            <a:solidFill>
+              <a:srgbClr val="E0E7FF"/>
+            </a:solidFill>
+            <a:prstDash val="solid"/>
+          </a:ln>
+          <a:effectLst>
+            <a:outerShdw sx="100000" sy="100000" kx="0" ky="0" algn="bl" rotWithShape="0" blurRad="127000" dist="38100" dir="5400000">
+              <a:srgbClr val="1E1B4B">
+                <a:alpha val="18000"/>
+              </a:srgbClr>
+            </a:outerShdw>
+          </a:effectLst>
+        </p:spPr>
+      </p:sp>
+      <p:pic>
+        <p:nvPicPr>
+          <p:cNvPr id="26" name="34-actions-trivy-scan.png" descr="34-actions-trivy-scan.png"/>
+          <p:cNvPicPr>
+            <a:picLocks noChangeAspect="1"/>
+          </p:cNvPicPr>
+          <p:nvPr/>
+        </p:nvPicPr>
+        <p:blipFill>
+          <a:blip r:embed="rId2"/>
+          <a:stretch>
+            <a:fillRect/>
+          </a:stretch>
+        </p:blipFill>
+        <p:spPr>
+          <a:xfrm>
+            <a:off x="612647" y="1709928"/>
+            <a:ext cx="5413248" cy="3247382"/>
+          </a:xfrm>
+          <a:prstGeom prst="rect">
+            <a:avLst/>
+          </a:prstGeom>
+        </p:spPr>
+      </p:pic>
+      <p:sp>
+        <p:nvSpPr>
+          <p:cNvPr id="24" name="caption 34-actions-trivy-scan.png"/>
+          <p:cNvSpPr txBox="1"/>
+          <p:nvPr/>
+        </p:nvSpPr>
+        <p:spPr>
+          <a:xfrm>
+            <a:off x="548640" y="5076182"/>
+            <a:ext cx="5541264" cy="256032"/>
+          </a:xfrm>
+          <a:prstGeom prst="rect">
+            <a:avLst/>
+          </a:prstGeom>
+          <a:noFill/>
+          <a:ln/>
+        </p:spPr>
+        <p:txBody>
+          <a:bodyPr wrap="square" lIns="0" tIns="0" rIns="0" bIns="0" rtlCol="0" anchor="ctr"/>
+          <a:lstStyle/>
+          <a:p>
+            <a:pPr algn="ctr" indent="0" marL="0">
+              <a:buNone/>
+            </a:pPr>
+            <a:r>
+              <a:rPr lang="en-US" sz="1100" i="1" dirty="0">
+                <a:solidFill>
+                  <a:schemeClr val="accent6"/>
+                </a:solidFill>
+              </a:rPr>
+              <a:t>Trivy scan step: fresh vulnerability DB, OS + Python packages, secrets</a:t>
+            </a:r>
+            <a:endParaRPr lang="en-US" sz="1100" dirty="0"/>
+          </a:p>
+        </p:txBody>
+      </p:sp>
+      <p:sp>
+        <p:nvSpPr>
+          <p:cNvPr id="22" name="card 35-actions-ghcr-login-push.png"/>
+          <p:cNvSpPr/>
+          <p:nvPr/>
+        </p:nvSpPr>
+        <p:spPr>
+          <a:xfrm>
+            <a:off x="6101791" y="1645920"/>
+            <a:ext cx="5541264" cy="3378223"/>
+          </a:xfrm>
+          <a:prstGeom prst="roundRect">
+            <a:avLst>
+              <a:gd name="adj" fmla="val 2039"/>
+            </a:avLst>
+          </a:prstGeom>
+          <a:solidFill>
+            <a:schemeClr val="bg1"/>
+          </a:solidFill>
+          <a:ln w="9525">
+            <a:solidFill>
+              <a:srgbClr val="E0E7FF"/>
+            </a:solidFill>
+            <a:prstDash val="solid"/>
+          </a:ln>
+          <a:effectLst>
+            <a:outerShdw sx="100000" sy="100000" kx="0" ky="0" algn="bl" rotWithShape="0" blurRad="127000" dist="38100" dir="5400000">
+              <a:srgbClr val="1E1B4B">
+                <a:alpha val="18000"/>
+              </a:srgbClr>
+            </a:outerShdw>
+          </a:effectLst>
+        </p:spPr>
+      </p:sp>
+      <p:pic>
+        <p:nvPicPr>
+          <p:cNvPr id="27" name="35-actions-ghcr-login-push.png" descr="35-actions-ghcr-login-push.png"/>
+          <p:cNvPicPr>
+            <a:picLocks noChangeAspect="1"/>
+          </p:cNvPicPr>
+          <p:nvPr/>
+        </p:nvPicPr>
+        <p:blipFill>
+          <a:blip r:embed="rId3"/>
+          <a:stretch>
+            <a:fillRect/>
+          </a:stretch>
+        </p:blipFill>
+        <p:spPr>
+          <a:xfrm>
+            <a:off x="6165799" y="1709928"/>
+            <a:ext cx="5413248" cy="3250207"/>
+          </a:xfrm>
+          <a:prstGeom prst="rect">
+            <a:avLst/>
+          </a:prstGeom>
+        </p:spPr>
+      </p:pic>
+      <p:sp>
+        <p:nvSpPr>
+          <p:cNvPr id="24" name="caption 35-actions-ghcr-login-push.png"/>
+          <p:cNvSpPr txBox="1"/>
+          <p:nvPr/>
+        </p:nvSpPr>
+        <p:spPr>
+          <a:xfrm>
+            <a:off x="6101791" y="5079007"/>
+            <a:ext cx="5541264" cy="256032"/>
+          </a:xfrm>
+          <a:prstGeom prst="rect">
+            <a:avLst/>
+          </a:prstGeom>
+          <a:noFill/>
+          <a:ln/>
+        </p:spPr>
+        <p:txBody>
+          <a:bodyPr wrap="square" lIns="0" tIns="0" rIns="0" bIns="0" rtlCol="0" anchor="ctr"/>
+          <a:lstStyle/>
+          <a:p>
+            <a:pPr algn="ctr" indent="0" marL="0">
+              <a:buNone/>
+            </a:pPr>
+            <a:r>
+              <a:rPr lang="en-US" sz="1100" i="1" dirty="0">
+                <a:solidFill>
+                  <a:schemeClr val="accent6"/>
+                </a:solidFill>
+              </a:rPr>
+              <a:t>Then the job logs in to ghcr.io with GITHUB_TOKEN and pushes</a:t>
+            </a:r>
+            <a:endParaRPr lang="en-US" sz="1100" dirty="0"/>
+          </a:p>
+        </p:txBody>
+      </p:sp>
+      <p:sp>
+        <p:nvSpPr>
+          <p:cNvPr id="21" name="pipeline note"/>
+          <p:cNvSpPr txBox="1"/>
+          <p:nvPr/>
+        </p:nvSpPr>
+        <p:spPr>
+          <a:xfrm>
+            <a:off x="548640" y="5623560"/>
+            <a:ext cx="11091672" cy="548640"/>
+          </a:xfrm>
+          <a:prstGeom prst="rect">
+            <a:avLst/>
+          </a:prstGeom>
+          <a:noFill/>
+          <a:ln/>
+        </p:spPr>
+        <p:txBody>
+          <a:bodyPr wrap="square" lIns="0" tIns="0" rIns="0" bIns="0" rtlCol="0" anchor="t"/>
+          <a:lstStyle/>
+          <a:p>
+            <a:pPr indent="0" marL="0">
+              <a:buNone/>
+            </a:pPr>
+            <a:r>
+              <a:rPr lang="en-US" sz="1400" dirty="0">
+                <a:solidFill>
+                  <a:schemeClr val="tx2"/>
+                </a:solidFill>
+              </a:rPr>
+              <a:t>The Trivy step runs with --exit-code 1 before the GHCR login: a fixable HIGH or CRITICAL CVE stops the job, so a vulnerable image is never pushed.</a:t>
+            </a:r>
+            <a:endParaRPr lang="en-US" sz="1400" dirty="0"/>
+          </a:p>
+        </p:txBody>
+      </p:sp>
+    </p:spTree>
+  </p:cSld>
+  <p:clrMapOvr>
+    <a:masterClrMapping/>
+  </p:clrMapOvr>
+</p:sld>
+</file>
+
+<file path=ppt/slides/slide12.xml><?xml version="1.0" encoding="utf-8"?>
 <p:sld xmlns:a="http://schemas.openxmlformats.org/drawingml/2006/main" xmlns:r="http://schemas.openxmlformats.org/officeDocument/2006/relationships" xmlns:p="http://schemas.openxmlformats.org/presentationml/2006/main">
   <p:cSld name="Slide 11">
     <p:spTree>
@@ -4693,7 +5128,7 @@
 </p:sld>
 </file>
 
-<file path=ppt/slides/slide12.xml><?xml version="1.0" encoding="utf-8"?>
+<file path=ppt/slides/slide13.xml><?xml version="1.0" encoding="utf-8"?>
 <p:sld xmlns:a="http://schemas.openxmlformats.org/drawingml/2006/main" xmlns:r="http://schemas.openxmlformats.org/officeDocument/2006/relationships" xmlns:p="http://schemas.openxmlformats.org/presentationml/2006/main">
   <p:cSld name="Slide 12">
     <p:spTree>
@@ -5511,7 +5946,7 @@
 </p:sld>
 </file>
 
-<file path=ppt/slides/slide13.xml><?xml version="1.0" encoding="utf-8"?>
+<file path=ppt/slides/slide14.xml><?xml version="1.0" encoding="utf-8"?>
 <p:sld xmlns:a="http://schemas.openxmlformats.org/drawingml/2006/main" xmlns:r="http://schemas.openxmlformats.org/officeDocument/2006/relationships" xmlns:p="http://schemas.openxmlformats.org/presentationml/2006/main">
   <p:cSld name="Slide 13">
     <p:spTree>
@@ -6208,7 +6643,7 @@
 </p:sld>
 </file>
 
-<file path=ppt/slides/slide14.xml><?xml version="1.0" encoding="utf-8"?>
+<file path=ppt/slides/slide15.xml><?xml version="1.0" encoding="utf-8"?>
 <p:sld xmlns:a="http://schemas.openxmlformats.org/drawingml/2006/main" xmlns:r="http://schemas.openxmlformats.org/officeDocument/2006/relationships" xmlns:p="http://schemas.openxmlformats.org/presentationml/2006/main">
   <p:cSld name="Slide 14">
     <p:spTree>
@@ -6950,7 +7385,7 @@
 </p:sld>
 </file>
 
-<file path=ppt/slides/slide15.xml><?xml version="1.0" encoding="utf-8"?>
+<file path=ppt/slides/slide16.xml><?xml version="1.0" encoding="utf-8"?>
 <p:sld xmlns:a="http://schemas.openxmlformats.org/drawingml/2006/main" xmlns:r="http://schemas.openxmlformats.org/officeDocument/2006/relationships" xmlns:p="http://schemas.openxmlformats.org/presentationml/2006/main">
   <p:cSld name="Slide 15">
     <p:spTree>
@@ -7590,7 +8025,7 @@
 </p:sld>
 </file>
 
-<file path=ppt/slides/slide16.xml><?xml version="1.0" encoding="utf-8"?>
+<file path=ppt/slides/slide17.xml><?xml version="1.0" encoding="utf-8"?>
 <p:sld xmlns:a="http://schemas.openxmlformats.org/drawingml/2006/main" xmlns:r="http://schemas.openxmlformats.org/officeDocument/2006/relationships" xmlns:p="http://schemas.openxmlformats.org/presentationml/2006/main">
   <p:cSld name="Slide 16">
     <p:spTree>
@@ -8490,7 +8925,7 @@
 </p:sld>
 </file>
 
-<file path=ppt/slides/slide17.xml><?xml version="1.0" encoding="utf-8"?>
+<file path=ppt/slides/slide18.xml><?xml version="1.0" encoding="utf-8"?>
 <p:sld xmlns:a="http://schemas.openxmlformats.org/drawingml/2006/main" xmlns:r="http://schemas.openxmlformats.org/officeDocument/2006/relationships" xmlns:p="http://schemas.openxmlformats.org/presentationml/2006/main">
   <p:cSld name="Slide 17">
     <p:spTree>
@@ -9228,7 +9663,7 @@
 </p:sld>
 </file>
 
-<file path=ppt/slides/slide18.xml><?xml version="1.0" encoding="utf-8"?>
+<file path=ppt/slides/slide19.xml><?xml version="1.0" encoding="utf-8"?>
 <p:sld xmlns:a="http://schemas.openxmlformats.org/drawingml/2006/main" xmlns:r="http://schemas.openxmlformats.org/officeDocument/2006/relationships" xmlns:p="http://schemas.openxmlformats.org/presentationml/2006/main">
   <p:cSld name="Slide 18">
     <p:spTree>

</xml_diff>

<commit_message>
Add container registry slide with SHA-tagged GHCR packages
</commit_message>
<xml_diff>
--- a/docs/DataDrift-Capstone-Presentation.pptx
+++ b/docs/DataDrift-Capstone-Presentation.pptx
@@ -16,6 +16,7 @@
     <p:sldId id="264" r:id="rId10"/>
     <p:sldId id="265" r:id="rId11"/>
     <p:sldId id="274" r:id="rId25"/>
+    <p:sldId id="275" r:id="rId26"/>
     <p:sldId id="266" r:id="rId12"/>
     <p:sldId id="267" r:id="rId13"/>
     <p:sldId id="268" r:id="rId14"/>
@@ -142,6 +143,7 @@
             <p14:sldId id="264"/>
             <p14:sldId id="265"/>
             <p14:sldId id="274"/>
+            <p14:sldId id="275"/>
           </p14:sldIdLst>
         </p14:section>
         <p14:section name="Infrastructure and runtime" id="{78cfe018-5433-16d0-b51c-b7f525af8985}">
@@ -1549,6 +1551,76 @@
         <p14:creationId xmlns:p14="http://schemas.microsoft.com/office/powerpoint/2010/main" val="1024086991"/>
       </p:ext>
     </p:extLst>
+  </p:cSld>
+  <p:clrMapOvr>
+    <a:masterClrMapping/>
+  </p:clrMapOvr>
+</p:notes>
+</file>
+
+<file path=ppt/notesSlides/notesSlide20.xml><?xml version="1.0" encoding="utf-8"?>
+<p:notes xmlns:a="http://schemas.openxmlformats.org/drawingml/2006/main" xmlns:p="http://schemas.openxmlformats.org/presentationml/2006/main" xmlns:r="http://schemas.openxmlformats.org/officeDocument/2006/relationships">
+  <p:cSld>
+    <p:spTree>
+      <p:nvGrpSpPr>
+        <p:cNvPr id="1" name=""/>
+        <p:cNvGrpSpPr/>
+        <p:nvPr/>
+      </p:nvGrpSpPr>
+      <p:grpSpPr>
+        <a:xfrm>
+          <a:off x="0" y="0"/>
+          <a:ext cx="0" cy="0"/>
+          <a:chOff x="0" y="0"/>
+          <a:chExt cx="0" cy="0"/>
+        </a:xfrm>
+      </p:grpSpPr>
+      <p:sp>
+        <p:nvSpPr>
+          <p:cNvPr id="2" name="Slide Image Placeholder 1"/>
+          <p:cNvSpPr>
+            <a:spLocks noGrp="1"/>
+          </p:cNvSpPr>
+          <p:nvPr>
+            <p:ph type="sldImg" idx="2"/>
+          </p:nvPr>
+        </p:nvSpPr>
+        <p:spPr/>
+      </p:sp>
+      <p:sp>
+        <p:nvSpPr>
+          <p:cNvPr id="3" name="Notes Placeholder 2"/>
+          <p:cNvSpPr>
+            <a:spLocks noGrp="1"/>
+          </p:cNvSpPr>
+          <p:nvPr>
+            <p:ph type="body" idx="3" sz="quarter"/>
+          </p:nvPr>
+        </p:nvSpPr>
+        <p:spPr/>
+        <p:txBody>
+          <a:bodyPr/>
+          <a:lstStyle/>
+          <a:p>
+            <a:r>
+              <a:t>These are the two packages in the GitHub Container Registry. Every version is tagged with the full Git commit SHA that built it, so the newest tag here, 269dc33, is the commit I pushed last. There is no latest tag: the Latest badge is only GitHub's label for the newest version. Because each tag is a commit, I can look at any running pod and know exactly which code it runs, and roll back to any earlier SHA with Helm. The packages are public, so the kind cluster pulls them without credentials.</a:t>
+            </a:r>
+          </a:p>
+        </p:txBody>
+      </p:sp>
+      <p:sp>
+        <p:nvSpPr>
+          <p:cNvPr id="4" name="Slide Number Placeholder 3"/>
+          <p:cNvSpPr>
+            <a:spLocks noGrp="1"/>
+          </p:cNvSpPr>
+          <p:nvPr>
+            <p:ph type="sldNum" idx="5" sz="quarter"/>
+          </p:nvPr>
+        </p:nvSpPr>
+        <p:spPr/>
+      </p:sp>
+    </p:spTree>
   </p:cSld>
   <p:clrMapOvr>
     <a:masterClrMapping/>
@@ -10517,6 +10589,369 @@
           </a:p>
         </p:txBody>
       </p:sp>
+    </p:spTree>
+  </p:cSld>
+  <p:clrMapOvr>
+    <a:masterClrMapping/>
+  </p:clrMapOvr>
+</p:sld>
+</file>
+
+<file path=ppt/slides/slide20.xml><?xml version="1.0" encoding="utf-8"?>
+<p:sld xmlns:a="http://schemas.openxmlformats.org/drawingml/2006/main" xmlns:p="http://schemas.openxmlformats.org/presentationml/2006/main" xmlns:r="http://schemas.openxmlformats.org/officeDocument/2006/relationships">
+  <p:cSld>
+    <p:spTree>
+      <p:nvGrpSpPr>
+        <p:cNvPr id="1" name=""/>
+        <p:cNvGrpSpPr/>
+        <p:nvPr/>
+      </p:nvGrpSpPr>
+      <p:grpSpPr/>
+      <p:sp>
+        <p:nvSpPr>
+          <p:cNvPr id="3" name="Text 0"/>
+          <p:cNvSpPr/>
+          <p:nvPr>
+            <p:ph idx="101" type="title" hasCustomPrompt="1"/>
+          </p:nvPr>
+        </p:nvSpPr>
+        <p:spPr>
+          <a:xfrm>
+            <a:off x="548640" y="621792"/>
+            <a:ext cx="11064240" cy="731520"/>
+          </a:xfrm>
+          <a:prstGeom prst="rect">
+            <a:avLst/>
+          </a:prstGeom>
+          <a:noFill/>
+          <a:ln/>
+        </p:spPr>
+        <p:txBody>
+          <a:bodyPr wrap="square" lIns="0" tIns="0" rIns="0" bIns="0" rtlCol="0" anchor="t"/>
+          <a:lstStyle/>
+          <a:p>
+            <a:pPr algn="l" indent="0" marL="0">
+              <a:buNone/>
+            </a:pPr>
+            <a:r>
+              <a:rPr lang="en-US" sz="3400" b="1" dirty="0">
+                <a:solidFill>
+                  <a:schemeClr val="tx1"/>
+                </a:solidFill>
+              </a:rPr>
+              <a:t>Every image is tagged with its commit</a:t>
+            </a:r>
+            <a:endParaRPr lang="en-US" sz="3400" dirty="0"/>
+          </a:p>
+        </p:txBody>
+      </p:sp>
+      <p:sp>
+        <p:nvSpPr>
+          <p:cNvPr id="2" name="Text 0"/>
+          <p:cNvSpPr/>
+          <p:nvPr>
+            <p:ph idx="100" type="body" hasCustomPrompt="1"/>
+          </p:nvPr>
+        </p:nvSpPr>
+        <p:spPr>
+          <a:xfrm>
+            <a:off x="548640" y="320040"/>
+            <a:ext cx="8229600" cy="292608"/>
+          </a:xfrm>
+          <a:prstGeom prst="rect">
+            <a:avLst/>
+          </a:prstGeom>
+          <a:noFill/>
+          <a:ln/>
+        </p:spPr>
+        <p:txBody>
+          <a:bodyPr wrap="square" lIns="0" tIns="0" rIns="0" bIns="0" rtlCol="0"/>
+          <a:lstStyle/>
+          <a:p>
+            <a:pPr indent="0" marL="0">
+              <a:buNone/>
+            </a:pPr>
+            <a:r>
+              <a:rPr lang="en-US" sz="1200" b="1" spc="200" kern="0" dirty="0">
+                <a:solidFill>
+                  <a:schemeClr val="accent1"/>
+                </a:solidFill>
+              </a:rPr>
+              <a:t>M5 · CONTAINER REGISTRY</a:t>
+            </a:r>
+            <a:endParaRPr lang="en-US" sz="1200" dirty="0"/>
+          </a:p>
+        </p:txBody>
+      </p:sp>
+      <p:sp>
+        <p:nvSpPr>
+          <p:cNvPr id="25" name="Slide Number Placeholder 0"/>
+          <p:cNvSpPr>
+            <a:spLocks noGrp="1"/>
+          </p:cNvSpPr>
+          <p:nvPr>
+            <p:ph type="sldNum" sz="quarter" idx="4294967295"/>
+          </p:nvPr>
+        </p:nvSpPr>
+        <p:spPr>
+          <a:xfrm>
+            <a:off x="11183112" y="6473952"/>
+            <a:ext cx="457200" cy="274320"/>
+          </a:xfrm>
+          <a:prstGeom prst="rect">
+            <a:avLst/>
+          </a:prstGeom>
+          <a:extLst>
+            <a:ext uri="{C572A759-6A51-4108-AA02-DFA0A04FC94B}">
+              <ma14:wrappingTextBoxFlag xmlns:ma14="http://schemas.microsoft.com/office/mac/drawingml/2011/main" val="0"/>
+            </a:ext>
+          </a:extLst>
+        </p:spPr>
+        <p:txBody>
+          <a:bodyPr lIns="0" tIns="0" rIns="0" bIns="0"/>
+          <a:lstStyle>
+            <a:lvl1pPr>
+              <a:defRPr sz="1000">
+                <a:solidFill>
+                  <a:srgbClr val="64748B"/>
+                </a:solidFill>
+              </a:defRPr>
+            </a:lvl1pPr>
+          </a:lstStyle>
+          <a:p>
+            <a:pPr algn="r"/>
+            <a:fld id="{F7021451-1387-4CA6-816F-3879F97B5CBC}" type="slidenum">
+              <a:rPr b="0" lang="en-US"/>
+              <a:t>10</a:t>
+            </a:fld>
+            <a:endParaRPr lang="en-US"/>
+          </a:p>
+        </p:txBody>
+      </p:sp>
+      <p:sp>
+        <p:nvSpPr>
+          <p:cNvPr id="22" name="card 36-ghcr-backend-package.png"/>
+          <p:cNvSpPr/>
+          <p:nvPr/>
+        </p:nvSpPr>
+        <p:spPr>
+          <a:xfrm>
+            <a:off x="548640" y="1645920"/>
+            <a:ext cx="5541264" cy="3375398"/>
+          </a:xfrm>
+          <a:prstGeom prst="roundRect">
+            <a:avLst>
+              <a:gd name="adj" fmla="val 2039"/>
+            </a:avLst>
+          </a:prstGeom>
+          <a:solidFill>
+            <a:schemeClr val="bg1"/>
+          </a:solidFill>
+          <a:ln w="9525">
+            <a:solidFill>
+              <a:srgbClr val="E0E7FF"/>
+            </a:solidFill>
+            <a:prstDash val="solid"/>
+          </a:ln>
+          <a:effectLst>
+            <a:outerShdw sx="100000" sy="100000" kx="0" ky="0" algn="bl" rotWithShape="0" blurRad="127000" dist="38100" dir="5400000">
+              <a:srgbClr val="1E1B4B">
+                <a:alpha val="18000"/>
+              </a:srgbClr>
+            </a:outerShdw>
+          </a:effectLst>
+        </p:spPr>
+      </p:sp>
+      <p:sp>
+        <p:nvSpPr>
+          <p:cNvPr id="24" name="caption 36-ghcr-backend-package.png"/>
+          <p:cNvSpPr txBox="1"/>
+          <p:nvPr/>
+        </p:nvSpPr>
+        <p:spPr>
+          <a:xfrm>
+            <a:off x="548640" y="5076182"/>
+            <a:ext cx="5541264" cy="256032"/>
+          </a:xfrm>
+          <a:prstGeom prst="rect">
+            <a:avLst/>
+          </a:prstGeom>
+          <a:noFill/>
+          <a:ln/>
+        </p:spPr>
+        <p:txBody>
+          <a:bodyPr wrap="square" lIns="0" tIns="0" rIns="0" bIns="0" rtlCol="0" anchor="ctr"/>
+          <a:lstStyle/>
+          <a:p>
+            <a:pPr algn="ctr" indent="0" marL="0">
+              <a:buNone/>
+            </a:pPr>
+            <a:r>
+              <a:rPr lang="en-US" sz="1100" i="1" dirty="0">
+                <a:solidFill>
+                  <a:schemeClr val="accent6"/>
+                </a:solidFill>
+              </a:rPr>
+              <a:t>ghcr.io/kavyadhyani/datadrift-backend: one tag per commit SHA</a:t>
+            </a:r>
+            <a:endParaRPr lang="en-US" sz="1100" dirty="0"/>
+          </a:p>
+        </p:txBody>
+      </p:sp>
+      <p:sp>
+        <p:nvSpPr>
+          <p:cNvPr id="22" name="card 37-ghcr-frontend-package.png"/>
+          <p:cNvSpPr/>
+          <p:nvPr/>
+        </p:nvSpPr>
+        <p:spPr>
+          <a:xfrm>
+            <a:off x="6101791" y="1645920"/>
+            <a:ext cx="5541264" cy="3378223"/>
+          </a:xfrm>
+          <a:prstGeom prst="roundRect">
+            <a:avLst>
+              <a:gd name="adj" fmla="val 2039"/>
+            </a:avLst>
+          </a:prstGeom>
+          <a:solidFill>
+            <a:schemeClr val="bg1"/>
+          </a:solidFill>
+          <a:ln w="9525">
+            <a:solidFill>
+              <a:srgbClr val="E0E7FF"/>
+            </a:solidFill>
+            <a:prstDash val="solid"/>
+          </a:ln>
+          <a:effectLst>
+            <a:outerShdw sx="100000" sy="100000" kx="0" ky="0" algn="bl" rotWithShape="0" blurRad="127000" dist="38100" dir="5400000">
+              <a:srgbClr val="1E1B4B">
+                <a:alpha val="18000"/>
+              </a:srgbClr>
+            </a:outerShdw>
+          </a:effectLst>
+        </p:spPr>
+      </p:sp>
+      <p:sp>
+        <p:nvSpPr>
+          <p:cNvPr id="24" name="caption 37-ghcr-frontend-package.png"/>
+          <p:cNvSpPr txBox="1"/>
+          <p:nvPr/>
+        </p:nvSpPr>
+        <p:spPr>
+          <a:xfrm>
+            <a:off x="6101791" y="5079007"/>
+            <a:ext cx="5541264" cy="256032"/>
+          </a:xfrm>
+          <a:prstGeom prst="rect">
+            <a:avLst/>
+          </a:prstGeom>
+          <a:noFill/>
+          <a:ln/>
+        </p:spPr>
+        <p:txBody>
+          <a:bodyPr wrap="square" lIns="0" tIns="0" rIns="0" bIns="0" rtlCol="0" anchor="ctr"/>
+          <a:lstStyle/>
+          <a:p>
+            <a:pPr algn="ctr" indent="0" marL="0">
+              <a:buNone/>
+            </a:pPr>
+            <a:r>
+              <a:rPr lang="en-US" sz="1100" i="1" dirty="0">
+                <a:solidFill>
+                  <a:schemeClr val="accent6"/>
+                </a:solidFill>
+              </a:rPr>
+              <a:t>ghcr.io/kavyadhyani/datadrift-frontend: the same SHAs</a:t>
+            </a:r>
+            <a:endParaRPr lang="en-US" sz="1100" dirty="0"/>
+          </a:p>
+        </p:txBody>
+      </p:sp>
+      <p:sp>
+        <p:nvSpPr>
+          <p:cNvPr id="21" name="pipeline note"/>
+          <p:cNvSpPr txBox="1"/>
+          <p:nvPr/>
+        </p:nvSpPr>
+        <p:spPr>
+          <a:xfrm>
+            <a:off x="548640" y="5623560"/>
+            <a:ext cx="11091672" cy="548640"/>
+          </a:xfrm>
+          <a:prstGeom prst="rect">
+            <a:avLst/>
+          </a:prstGeom>
+          <a:noFill/>
+          <a:ln/>
+        </p:spPr>
+        <p:txBody>
+          <a:bodyPr wrap="square" lIns="0" tIns="0" rIns="0" bIns="0" rtlCol="0" anchor="t"/>
+          <a:lstStyle/>
+          <a:p>
+            <a:pPr indent="0" marL="0">
+              <a:buNone/>
+            </a:pPr>
+            <a:r>
+              <a:rPr lang="en-US" sz="1400" dirty="0">
+                <a:solidFill>
+                  <a:schemeClr val="tx2"/>
+                </a:solidFill>
+              </a:rPr>
+              <a:t>Both packages are public, so the cluster pulls them anonymously. A running pod’s image tag points straight back to the commit that built it, and no image is ever tagged latest.</a:t>
+            </a:r>
+            <a:endParaRPr lang="en-US" sz="1400" dirty="0"/>
+          </a:p>
+        </p:txBody>
+      </p:sp>
+      <p:pic>
+        <p:nvPicPr>
+          <p:cNvPr id="26" name="36-ghcr-backend-package.png" descr="36-ghcr-backend-package.png"/>
+          <p:cNvPicPr>
+            <a:picLocks noChangeAspect="1"/>
+          </p:cNvPicPr>
+          <p:nvPr/>
+        </p:nvPicPr>
+        <p:blipFill>
+          <a:blip r:embed="rId2"/>
+          <a:stretch>
+            <a:fillRect/>
+          </a:stretch>
+        </p:blipFill>
+        <p:spPr>
+          <a:xfrm>
+            <a:off x="612647" y="1709928"/>
+            <a:ext cx="5413248" cy="3247382"/>
+          </a:xfrm>
+          <a:prstGeom prst="rect">
+            <a:avLst/>
+          </a:prstGeom>
+        </p:spPr>
+      </p:pic>
+      <p:pic>
+        <p:nvPicPr>
+          <p:cNvPr id="27" name="37-ghcr-frontend-package.png" descr="37-ghcr-frontend-package.png"/>
+          <p:cNvPicPr>
+            <a:picLocks noChangeAspect="1"/>
+          </p:cNvPicPr>
+          <p:nvPr/>
+        </p:nvPicPr>
+        <p:blipFill>
+          <a:blip r:embed="rId3"/>
+          <a:stretch>
+            <a:fillRect/>
+          </a:stretch>
+        </p:blipFill>
+        <p:spPr>
+          <a:xfrm>
+            <a:off x="6165799" y="1709928"/>
+            <a:ext cx="5413248" cy="3250207"/>
+          </a:xfrm>
+          <a:prstGeom prst="rect">
+            <a:avLst/>
+          </a:prstGeom>
+        </p:spPr>
+      </p:pic>
     </p:spTree>
   </p:cSld>
   <p:clrMapOvr>

</xml_diff>